<commit_message>
Correction noms presentation stage (CoAI, Ilias Baadji)
</commit_message>
<xml_diff>
--- a/Stage/BnDrS_Soutenance_stage.pptx
+++ b/Stage/BnDrS_Soutenance_stage.pptx
@@ -4375,7 +4375,7 @@
                 </a:solidFill>
                 <a:latin typeface="Inter"/>
               </a:rPr>
-              <a:t>Association Koh AI</a:t>
+              <a:t>Association CoAI</a:t>
             </a:r>
           </a:p>
         </p:txBody>
@@ -4465,7 +4465,7 @@
                 </a:solidFill>
                 <a:latin typeface="Inter"/>
               </a:rPr>
-              <a:t>Elias Baadgji</a:t>
+              <a:t>Ilias Baadji</a:t>
             </a:r>
           </a:p>
         </p:txBody>
@@ -8971,7 +8971,7 @@
                 </a:solidFill>
                 <a:latin typeface="Inter"/>
               </a:rPr>
-              <a:t>Ce stage chez Koh AI m’a permis de couvrir </a:t>
+              <a:t>Ce stage chez CoAI m’a permis de couvrir </a:t>
             </a:r>
             <a:r>
               <a:rPr sz="1400" b="1" i="0">
@@ -11663,7 +11663,7 @@
                 </a:solidFill>
                 <a:latin typeface="Inter"/>
               </a:rPr>
-              <a:t>Stéphane Holtzmann — DEV IA · Greta de Besançon   ·   Stage chez Koh AI</a:t>
+              <a:t>Stéphane Holtzmann — DEV IA · Greta de Besançon   ·   Stage chez CoAI</a:t>
             </a:r>
           </a:p>
         </p:txBody>
@@ -12042,7 +12042,7 @@
                 </a:solidFill>
                 <a:latin typeface="Inter"/>
               </a:rPr>
-              <a:t>Koh AI · stage 1ʳᵉ année en distanciel</a:t>
+              <a:t>CoAI · stage 1ʳᵉ année en distanciel</a:t>
             </a:r>
           </a:p>
         </p:txBody>
@@ -13564,7 +13564,7 @@
                 </a:solidFill>
                 <a:latin typeface="Inter"/>
               </a:rPr>
-              <a:t>Koh AI — l’association &amp; le cadre du stage</a:t>
+              <a:t>CoAI — l’association &amp; le cadre du stage</a:t>
             </a:r>
           </a:p>
         </p:txBody>
@@ -13659,7 +13659,7 @@
                 </a:solidFill>
                 <a:latin typeface="Inter"/>
               </a:rPr>
-              <a:t>Association Koh AI</a:t>
+              <a:t>Association CoAI</a:t>
             </a:r>
           </a:p>
         </p:txBody>

</xml_diff>